<commit_message>
⑤ deck adds only panel letters (figure number stays in the caption)
The markdown captions already number the figures (**图4.18** …), so baking
"图 X.Y" into the exported image double-numbered it. The PPT now adds only the
(a)(b)(c) panel letters; the figure number comes from the caption. Also tighten
the auto-deck slide so the export carries no surrounding whitespace.

Co-Authored-By: Claude Opus 4.8 <noreply@anthropic.com>
</commit_message>
<xml_diff>
--- a/article/ppt/autofigs_ch04.pptx
+++ b/article/ppt/autofigs_ch04.pptx
@@ -8,7 +8,7 @@
     <p:sldId id="256" r:id="rId7"/>
     <p:sldId id="257" r:id="rId8"/>
   </p:sldIdLst>
-  <p:sldSz cx="12188952" cy="4754880" type="screen4x3"/>
+  <p:sldSz cx="12188952" cy="4023360" type="screen4x3"/>
   <p:notesSz cx="6858000" cy="9144000"/>
   <p:defaultTextStyle>
     <a:defPPr>
@@ -3105,7 +3105,7 @@
         </p:blipFill>
         <p:spPr>
           <a:xfrm>
-            <a:off x="228600" y="658368"/>
+            <a:off x="228600" y="411480"/>
             <a:ext cx="3837431" cy="3241968"/>
           </a:xfrm>
           <a:prstGeom prst="rect">
@@ -3121,7 +3121,7 @@
         </p:nvSpPr>
         <p:spPr>
           <a:xfrm>
-            <a:off x="228600" y="274320"/>
+            <a:off x="228600" y="27432"/>
             <a:ext cx="640080" cy="365760"/>
           </a:xfrm>
           <a:prstGeom prst="rect">
@@ -3162,7 +3162,7 @@
         </p:blipFill>
         <p:spPr>
           <a:xfrm>
-            <a:off x="4175760" y="658368"/>
+            <a:off x="4175760" y="411480"/>
             <a:ext cx="3837431" cy="3109184"/>
           </a:xfrm>
           <a:prstGeom prst="rect">
@@ -3178,7 +3178,7 @@
         </p:nvSpPr>
         <p:spPr>
           <a:xfrm>
-            <a:off x="4175760" y="274320"/>
+            <a:off x="4175760" y="27432"/>
             <a:ext cx="640080" cy="365760"/>
           </a:xfrm>
           <a:prstGeom prst="rect">
@@ -3219,7 +3219,7 @@
         </p:blipFill>
         <p:spPr>
           <a:xfrm>
-            <a:off x="8122920" y="658368"/>
+            <a:off x="8122920" y="411480"/>
             <a:ext cx="3837431" cy="3353269"/>
           </a:xfrm>
           <a:prstGeom prst="rect">
@@ -3235,7 +3235,7 @@
         </p:nvSpPr>
         <p:spPr>
           <a:xfrm>
-            <a:off x="8122920" y="274320"/>
+            <a:off x="8122920" y="27432"/>
             <a:ext cx="640080" cy="365760"/>
           </a:xfrm>
           <a:prstGeom prst="rect">
@@ -3256,39 +3256,6 @@
                 </a:solidFill>
               </a:rPr>
               <a:t>(c)</a:t>
-            </a:r>
-          </a:p>
-        </p:txBody>
-      </p:sp>
-      <p:sp>
-        <p:nvSpPr>
-          <p:cNvPr id="8" name="TextBox 7"/>
-          <p:cNvSpPr txBox="1"/>
-          <p:nvPr/>
-        </p:nvSpPr>
-        <p:spPr>
-          <a:xfrm>
-            <a:off x="228600" y="73152"/>
-            <a:ext cx="2743200" cy="365760"/>
-          </a:xfrm>
-          <a:prstGeom prst="rect">
-            <a:avLst/>
-          </a:prstGeom>
-          <a:noFill/>
-        </p:spPr>
-        <p:txBody>
-          <a:bodyPr wrap="none">
-            <a:spAutoFit/>
-          </a:bodyPr>
-          <a:lstStyle/>
-          <a:p>
-            <a:r>
-              <a:rPr b="1" sz="1600">
-                <a:solidFill>
-                  <a:srgbClr val="3F2A7A"/>
-                </a:solidFill>
-              </a:rPr>
-              <a:t>图 4.16</a:t>
             </a:r>
           </a:p>
         </p:txBody>
@@ -3327,7 +3294,7 @@
         </p:blipFill>
         <p:spPr>
           <a:xfrm>
-            <a:off x="228600" y="658368"/>
+            <a:off x="228600" y="411480"/>
             <a:ext cx="3837431" cy="3180849"/>
           </a:xfrm>
           <a:prstGeom prst="rect">
@@ -3343,7 +3310,7 @@
         </p:nvSpPr>
         <p:spPr>
           <a:xfrm>
-            <a:off x="228600" y="274320"/>
+            <a:off x="228600" y="27432"/>
             <a:ext cx="640080" cy="365760"/>
           </a:xfrm>
           <a:prstGeom prst="rect">
@@ -3384,7 +3351,7 @@
         </p:blipFill>
         <p:spPr>
           <a:xfrm>
-            <a:off x="4175760" y="658368"/>
+            <a:off x="4175760" y="411480"/>
             <a:ext cx="3837431" cy="3231702"/>
           </a:xfrm>
           <a:prstGeom prst="rect">
@@ -3400,7 +3367,7 @@
         </p:nvSpPr>
         <p:spPr>
           <a:xfrm>
-            <a:off x="4175760" y="274320"/>
+            <a:off x="4175760" y="27432"/>
             <a:ext cx="640080" cy="365760"/>
           </a:xfrm>
           <a:prstGeom prst="rect">
@@ -3441,7 +3408,7 @@
         </p:blipFill>
         <p:spPr>
           <a:xfrm>
-            <a:off x="8122920" y="658368"/>
+            <a:off x="8122920" y="411480"/>
             <a:ext cx="3837431" cy="3203570"/>
           </a:xfrm>
           <a:prstGeom prst="rect">
@@ -3457,7 +3424,7 @@
         </p:nvSpPr>
         <p:spPr>
           <a:xfrm>
-            <a:off x="8122920" y="274320"/>
+            <a:off x="8122920" y="27432"/>
             <a:ext cx="640080" cy="365760"/>
           </a:xfrm>
           <a:prstGeom prst="rect">
@@ -3478,39 +3445,6 @@
                 </a:solidFill>
               </a:rPr>
               <a:t>(c)</a:t>
-            </a:r>
-          </a:p>
-        </p:txBody>
-      </p:sp>
-      <p:sp>
-        <p:nvSpPr>
-          <p:cNvPr id="8" name="TextBox 7"/>
-          <p:cNvSpPr txBox="1"/>
-          <p:nvPr/>
-        </p:nvSpPr>
-        <p:spPr>
-          <a:xfrm>
-            <a:off x="228600" y="73152"/>
-            <a:ext cx="2743200" cy="365760"/>
-          </a:xfrm>
-          <a:prstGeom prst="rect">
-            <a:avLst/>
-          </a:prstGeom>
-          <a:noFill/>
-        </p:spPr>
-        <p:txBody>
-          <a:bodyPr wrap="none">
-            <a:spAutoFit/>
-          </a:bodyPr>
-          <a:lstStyle/>
-          <a:p>
-            <a:r>
-              <a:rPr b="1" sz="1600">
-                <a:solidFill>
-                  <a:srgbClr val="3F2A7A"/>
-                </a:solidFill>
-              </a:rPr>
-              <a:t>图 4.18</a:t>
             </a:r>
           </a:p>
         </p:txBody>

</xml_diff>

<commit_message>
⑥⑧①②⑤ comparison panels: direct labels (no legend) + panel-letter fixes
- ⑥ design_cmp_panel now labels points DIRECTLY in the panel (no legend):
  markers that share an x are jittered apart, "ours" is labelled at its marker,
  literature designs get a leader-lined label column.
- ⑧ the two "ours" SAR points are disambiguated -> "ours" (plain SA) vs
  "ours (auto-zero)".
- ①②⑤ (PPT panel letters) now black (not purple), no-wrap so "(a)" stays on one
  line, and placed closer to each panel.
- ⑦ figure-content norms recorded in memory (no hard-coded chapter/draft strings
  or Chinese in code-drawn images; comparison = direct labels not legend).

Co-Authored-By: Claude Opus 4.8 <noreply@anthropic.com>
</commit_message>
<xml_diff>
--- a/article/ppt/autofigs_ch04.pptx
+++ b/article/ppt/autofigs_ch04.pptx
@@ -3121,8 +3121,8 @@
         </p:nvSpPr>
         <p:spPr>
           <a:xfrm>
-            <a:off x="228600" y="27432"/>
-            <a:ext cx="640080" cy="365760"/>
+            <a:off x="274320" y="137160"/>
+            <a:ext cx="914400" cy="292608"/>
           </a:xfrm>
           <a:prstGeom prst="rect">
             <a:avLst/>
@@ -3130,15 +3130,15 @@
           <a:noFill/>
         </p:spPr>
         <p:txBody>
-          <a:bodyPr wrap="none">
+          <a:bodyPr wrap="none" lIns="0" rIns="0" tIns="0" bIns="0">
             <a:spAutoFit/>
           </a:bodyPr>
           <a:lstStyle/>
           <a:p>
             <a:r>
-              <a:rPr b="1" sz="1500">
+              <a:rPr b="1" sz="1400">
                 <a:solidFill>
-                  <a:srgbClr val="3F2A7A"/>
+                  <a:srgbClr val="202020"/>
                 </a:solidFill>
               </a:rPr>
               <a:t>(a)</a:t>
@@ -3178,8 +3178,8 @@
         </p:nvSpPr>
         <p:spPr>
           <a:xfrm>
-            <a:off x="4175760" y="27432"/>
-            <a:ext cx="640080" cy="365760"/>
+            <a:off x="4221480" y="137160"/>
+            <a:ext cx="914400" cy="292608"/>
           </a:xfrm>
           <a:prstGeom prst="rect">
             <a:avLst/>
@@ -3187,15 +3187,15 @@
           <a:noFill/>
         </p:spPr>
         <p:txBody>
-          <a:bodyPr wrap="none">
+          <a:bodyPr wrap="none" lIns="0" rIns="0" tIns="0" bIns="0">
             <a:spAutoFit/>
           </a:bodyPr>
           <a:lstStyle/>
           <a:p>
             <a:r>
-              <a:rPr b="1" sz="1500">
+              <a:rPr b="1" sz="1400">
                 <a:solidFill>
-                  <a:srgbClr val="3F2A7A"/>
+                  <a:srgbClr val="202020"/>
                 </a:solidFill>
               </a:rPr>
               <a:t>(b)</a:t>
@@ -3235,8 +3235,8 @@
         </p:nvSpPr>
         <p:spPr>
           <a:xfrm>
-            <a:off x="8122920" y="27432"/>
-            <a:ext cx="640080" cy="365760"/>
+            <a:off x="8168640" y="137160"/>
+            <a:ext cx="914400" cy="292608"/>
           </a:xfrm>
           <a:prstGeom prst="rect">
             <a:avLst/>
@@ -3244,15 +3244,15 @@
           <a:noFill/>
         </p:spPr>
         <p:txBody>
-          <a:bodyPr wrap="none">
+          <a:bodyPr wrap="none" lIns="0" rIns="0" tIns="0" bIns="0">
             <a:spAutoFit/>
           </a:bodyPr>
           <a:lstStyle/>
           <a:p>
             <a:r>
-              <a:rPr b="1" sz="1500">
+              <a:rPr b="1" sz="1400">
                 <a:solidFill>
-                  <a:srgbClr val="3F2A7A"/>
+                  <a:srgbClr val="202020"/>
                 </a:solidFill>
               </a:rPr>
               <a:t>(c)</a:t>
@@ -3295,7 +3295,7 @@
         <p:spPr>
           <a:xfrm>
             <a:off x="228600" y="411480"/>
-            <a:ext cx="3837431" cy="3180849"/>
+            <a:ext cx="3837431" cy="3164019"/>
           </a:xfrm>
           <a:prstGeom prst="rect">
             <a:avLst/>
@@ -3310,8 +3310,8 @@
         </p:nvSpPr>
         <p:spPr>
           <a:xfrm>
-            <a:off x="228600" y="27432"/>
-            <a:ext cx="640080" cy="365760"/>
+            <a:off x="274320" y="137160"/>
+            <a:ext cx="914400" cy="292608"/>
           </a:xfrm>
           <a:prstGeom prst="rect">
             <a:avLst/>
@@ -3319,15 +3319,15 @@
           <a:noFill/>
         </p:spPr>
         <p:txBody>
-          <a:bodyPr wrap="none">
+          <a:bodyPr wrap="none" lIns="0" rIns="0" tIns="0" bIns="0">
             <a:spAutoFit/>
           </a:bodyPr>
           <a:lstStyle/>
           <a:p>
             <a:r>
-              <a:rPr b="1" sz="1500">
+              <a:rPr b="1" sz="1400">
                 <a:solidFill>
-                  <a:srgbClr val="3F2A7A"/>
+                  <a:srgbClr val="202020"/>
                 </a:solidFill>
               </a:rPr>
               <a:t>(a)</a:t>
@@ -3352,7 +3352,7 @@
         <p:spPr>
           <a:xfrm>
             <a:off x="4175760" y="411480"/>
-            <a:ext cx="3837431" cy="3231702"/>
+            <a:ext cx="3837431" cy="3211540"/>
           </a:xfrm>
           <a:prstGeom prst="rect">
             <a:avLst/>
@@ -3367,8 +3367,8 @@
         </p:nvSpPr>
         <p:spPr>
           <a:xfrm>
-            <a:off x="4175760" y="27432"/>
-            <a:ext cx="640080" cy="365760"/>
+            <a:off x="4221480" y="137160"/>
+            <a:ext cx="914400" cy="292608"/>
           </a:xfrm>
           <a:prstGeom prst="rect">
             <a:avLst/>
@@ -3376,15 +3376,15 @@
           <a:noFill/>
         </p:spPr>
         <p:txBody>
-          <a:bodyPr wrap="none">
+          <a:bodyPr wrap="none" lIns="0" rIns="0" tIns="0" bIns="0">
             <a:spAutoFit/>
           </a:bodyPr>
           <a:lstStyle/>
           <a:p>
             <a:r>
-              <a:rPr b="1" sz="1500">
+              <a:rPr b="1" sz="1400">
                 <a:solidFill>
-                  <a:srgbClr val="3F2A7A"/>
+                  <a:srgbClr val="202020"/>
                 </a:solidFill>
               </a:rPr>
               <a:t>(b)</a:t>
@@ -3409,7 +3409,7 @@
         <p:spPr>
           <a:xfrm>
             <a:off x="8122920" y="411480"/>
-            <a:ext cx="3837431" cy="3203570"/>
+            <a:ext cx="3837431" cy="3232431"/>
           </a:xfrm>
           <a:prstGeom prst="rect">
             <a:avLst/>
@@ -3424,8 +3424,8 @@
         </p:nvSpPr>
         <p:spPr>
           <a:xfrm>
-            <a:off x="8122920" y="27432"/>
-            <a:ext cx="640080" cy="365760"/>
+            <a:off x="8168640" y="137160"/>
+            <a:ext cx="914400" cy="292608"/>
           </a:xfrm>
           <a:prstGeom prst="rect">
             <a:avLst/>
@@ -3433,15 +3433,15 @@
           <a:noFill/>
         </p:spPr>
         <p:txBody>
-          <a:bodyPr wrap="none">
+          <a:bodyPr wrap="none" lIns="0" rIns="0" tIns="0" bIns="0">
             <a:spAutoFit/>
           </a:bodyPr>
           <a:lstStyle/>
           <a:p>
             <a:r>
-              <a:rPr b="1" sz="1500">
+              <a:rPr b="1" sz="1400">
                 <a:solidFill>
-                  <a:srgbClr val="3F2A7A"/>
+                  <a:srgbClr val="202020"/>
                 </a:solidFill>
               </a:rPr>
               <a:t>(c)</a:t>

</xml_diff>